<commit_message>
PPTX: verificările din browser rulate pe v1.55.0
Co-Authored-By: Claude Sonnet 5.5 <noreply@anthropic.com>
Claude-Session: https://claude.ai/code/session_012pMN9nfLxMNp2bEdSiwWEp
</commit_message>
<xml_diff>
--- a/docs/prezentari/Prezentare_workshop_v1.55.0.pptx
+++ b/docs/prezentari/Prezentare_workshop_v1.55.0.pptx
@@ -120,21 +120,21 @@
   <p:extLst>
     <p:ext uri="{521415D9-36F7-43E2-AB2F-B90AF26B5E84}">
       <p14:sectionLst xmlns:p14="http://schemas.microsoft.com/office/powerpoint/2010/main">
-        <p14:section name="Introducere" id="{4cd67a48-f8b4-7baf-7b56-883925d4a04d}">
+        <p14:section name="Introducere" id="{9ca2a6de-82e4-7e23-a5d2-96a1a37f2ec7}">
           <p14:sldIdLst>
             <p14:sldId id="256"/>
             <p14:sldId id="257"/>
             <p14:sldId id="258"/>
           </p14:sldIdLst>
         </p14:section>
-        <p14:section name="Aplicația" id="{fa26f7d6-0921-b272-11e0-d5102fb577e0}">
+        <p14:section name="Aplicația" id="{3f88de0d-4b1a-ffc4-2440-76ddc923e918}">
           <p14:sldIdLst>
             <p14:sldId id="259"/>
             <p14:sldId id="260"/>
             <p14:sldId id="261"/>
           </p14:sldIdLst>
         </p14:section>
-        <p14:section name="Decizie și integritate" id="{9b177760-b742-8689-f061-850b1b3a488d}">
+        <p14:section name="Decizie și integritate" id="{e6f13a68-867e-4570-af1f-26745d4ec598}">
           <p14:sldIdLst>
             <p14:sldId id="262"/>
             <p14:sldId id="263"/>
@@ -142,7 +142,7 @@
             <p14:sldId id="265"/>
           </p14:sldIdLst>
         </p14:section>
-        <p14:section name="Distribuție și limite" id="{3fc8b5d8-919d-165a-93dd-0acdf2a949ec}">
+        <p14:section name="Distribuție și limite" id="{c98f02f0-441b-32d2-22b1-952008951502}">
           <p14:sldIdLst>
             <p14:sldId id="266"/>
             <p14:sldId id="267"/>
@@ -3845,7 +3845,7 @@
                   <a:schemeClr val="tx1"/>
                 </a:solidFill>
               </a:rPr>
-              <a:t>45 de verificări într-un browser fără interfață, pe scenariul din v1.54.0.</a:t>
+              <a:t>45 de verificări într-un browser fără interfață, pe scenariul rulat pe v1.55.0.</a:t>
             </a:r>
             <a:endParaRPr lang="en-US" sz="1700" dirty="0"/>
           </a:p>

</xml_diff>

<commit_message>
Titular: Toma Radu Cristian; proiect METROFOOD (NOTICE, package.json, README, PPTX)
Co-Authored-By: Claude Sonnet 5.5 <noreply@anthropic.com>
Claude-Session: https://claude.ai/code/session_012pMN9nfLxMNp2bEdSiwWEp
</commit_message>
<xml_diff>
--- a/docs/prezentari/Prezentare_workshop_v1.55.0.pptx
+++ b/docs/prezentari/Prezentare_workshop_v1.55.0.pptx
@@ -120,21 +120,21 @@
   <p:extLst>
     <p:ext uri="{521415D9-36F7-43E2-AB2F-B90AF26B5E84}">
       <p14:sectionLst xmlns:p14="http://schemas.microsoft.com/office/powerpoint/2010/main">
-        <p14:section name="Introducere" id="{9ca2a6de-82e4-7e23-a5d2-96a1a37f2ec7}">
+        <p14:section name="Introducere" id="{75697309-0d5c-5548-7e13-f85b1f9db9c5}">
           <p14:sldIdLst>
             <p14:sldId id="256"/>
             <p14:sldId id="257"/>
             <p14:sldId id="258"/>
           </p14:sldIdLst>
         </p14:section>
-        <p14:section name="Aplicația" id="{3f88de0d-4b1a-ffc4-2440-76ddc923e918}">
+        <p14:section name="Aplicația" id="{6f715332-d572-1bd1-ba4b-d758bdff6b57}">
           <p14:sldIdLst>
             <p14:sldId id="259"/>
             <p14:sldId id="260"/>
             <p14:sldId id="261"/>
           </p14:sldIdLst>
         </p14:section>
-        <p14:section name="Decizie și integritate" id="{e6f13a68-867e-4570-af1f-26745d4ec598}">
+        <p14:section name="Decizie și integritate" id="{112b9367-5416-c512-b27b-2ea53a0444ed}">
           <p14:sldIdLst>
             <p14:sldId id="262"/>
             <p14:sldId id="263"/>
@@ -142,7 +142,7 @@
             <p14:sldId id="265"/>
           </p14:sldIdLst>
         </p14:section>
-        <p14:section name="Distribuție și limite" id="{c98f02f0-441b-32d2-22b1-952008951502}">
+        <p14:section name="Distribuție și limite" id="{a036f87b-41de-806a-501a-cab78ea11df7}">
           <p14:sldIdLst>
             <p14:sldId id="266"/>
             <p14:sldId id="267"/>

</xml_diff>

<commit_message>
Contact de securitate și de prezentare: info.lab@bth.usamv.ro
Co-Authored-By: Claude Sonnet 5.5 <noreply@anthropic.com>
Claude-Session: https://claude.ai/code/session_012pMN9nfLxMNp2bEdSiwWEp
</commit_message>
<xml_diff>
--- a/docs/prezentari/Prezentare_workshop_v1.55.0.pptx
+++ b/docs/prezentari/Prezentare_workshop_v1.55.0.pptx
@@ -120,21 +120,21 @@
   <p:extLst>
     <p:ext uri="{521415D9-36F7-43E2-AB2F-B90AF26B5E84}">
       <p14:sectionLst xmlns:p14="http://schemas.microsoft.com/office/powerpoint/2010/main">
-        <p14:section name="Introducere" id="{75697309-0d5c-5548-7e13-f85b1f9db9c5}">
+        <p14:section name="Introducere" id="{d13a82c6-7cbf-37de-47ca-35d4acb08028}">
           <p14:sldIdLst>
             <p14:sldId id="256"/>
             <p14:sldId id="257"/>
             <p14:sldId id="258"/>
           </p14:sldIdLst>
         </p14:section>
-        <p14:section name="Aplicația" id="{6f715332-d572-1bd1-ba4b-d758bdff6b57}">
+        <p14:section name="Aplicația" id="{4330398b-8e5b-7d7c-6f6d-9cd8fbda3180}">
           <p14:sldIdLst>
             <p14:sldId id="259"/>
             <p14:sldId id="260"/>
             <p14:sldId id="261"/>
           </p14:sldIdLst>
         </p14:section>
-        <p14:section name="Decizie și integritate" id="{112b9367-5416-c512-b27b-2ea53a0444ed}">
+        <p14:section name="Decizie și integritate" id="{97d32bb6-a77c-3e08-ea1d-5f1204a74fb7}">
           <p14:sldIdLst>
             <p14:sldId id="262"/>
             <p14:sldId id="263"/>
@@ -142,7 +142,7 @@
             <p14:sldId id="265"/>
           </p14:sldIdLst>
         </p14:section>
-        <p14:section name="Distribuție și limite" id="{a036f87b-41de-806a-501a-cab78ea11df7}">
+        <p14:section name="Distribuție și limite" id="{6cfb630a-12ac-154c-6532-05a63cfb1399}">
           <p14:sldIdLst>
             <p14:sldId id="266"/>
             <p14:sldId id="267"/>
@@ -4490,7 +4490,7 @@
                   <a:schemeClr val="tx1"/>
                 </a:solidFill>
               </a:rPr>
-              <a:t>[de completat: adresă de contact]</a:t>
+              <a:t>info.lab@bth.usamv.ro</a:t>
             </a:r>
             <a:endParaRPr lang="en-US" sz="1600" dirty="0"/>
           </a:p>

</xml_diff>

<commit_message>
Corecții: codificare UTF-8 în demo-ul animat; formularea numărului de dependențe
- Demo_animat: document HTML complet, cu <!doctype>, <meta charset="utf-8"> și viewport
- Prezentare, diapozitivul 12: „110 pachete de execuție instalate, din care 7 dependențe directe”
- scripts/license-check.js: aceeași formulare

Co-Authored-By: Claude Sonnet 5.5 <noreply@anthropic.com>
Claude-Session: https://claude.ai/code/session_012pMN9nfLxMNp2bEdSiwWEp
</commit_message>
<xml_diff>
--- a/docs/prezentari/Prezentare_workshop_v1.55.0.pptx
+++ b/docs/prezentari/Prezentare_workshop_v1.55.0.pptx
@@ -120,21 +120,21 @@
   <p:extLst>
     <p:ext uri="{521415D9-36F7-43E2-AB2F-B90AF26B5E84}">
       <p14:sectionLst xmlns:p14="http://schemas.microsoft.com/office/powerpoint/2010/main">
-        <p14:section name="Introducere" id="{d13a82c6-7cbf-37de-47ca-35d4acb08028}">
+        <p14:section name="Introducere" id="{c82d456f-ca72-a9eb-02b0-732d9273fd73}">
           <p14:sldIdLst>
             <p14:sldId id="256"/>
             <p14:sldId id="257"/>
             <p14:sldId id="258"/>
           </p14:sldIdLst>
         </p14:section>
-        <p14:section name="Aplicația" id="{4330398b-8e5b-7d7c-6f6d-9cd8fbda3180}">
+        <p14:section name="Aplicația" id="{151246d2-c605-0e23-1afc-0f2a3d544e57}">
           <p14:sldIdLst>
             <p14:sldId id="259"/>
             <p14:sldId id="260"/>
             <p14:sldId id="261"/>
           </p14:sldIdLst>
         </p14:section>
-        <p14:section name="Decizie și integritate" id="{97d32bb6-a77c-3e08-ea1d-5f1204a74fb7}">
+        <p14:section name="Decizie și integritate" id="{5e6cc5d4-29a3-11ed-9a9e-bd6c4136dc7b}">
           <p14:sldIdLst>
             <p14:sldId id="262"/>
             <p14:sldId id="263"/>
@@ -142,7 +142,7 @@
             <p14:sldId id="265"/>
           </p14:sldIdLst>
         </p14:section>
-        <p14:section name="Distribuție și limite" id="{6cfb630a-12ac-154c-6532-05a63cfb1399}">
+        <p14:section name="Distribuție și limite" id="{7082ad20-6511-cc1a-dfc8-633fe266e73c}">
           <p14:sldIdLst>
             <p14:sldId id="266"/>
             <p14:sldId id="267"/>
@@ -3462,7 +3462,7 @@
                   <a:schemeClr val="tx1"/>
                 </a:solidFill>
               </a:rPr>
-              <a:t>dependențe de execuție, toate cu licențe permisive</a:t>
+              <a:t>pachete de execuție instalate, din care 7 dependențe directe; toate cu licențe permisive</a:t>
             </a:r>
             <a:endParaRPr lang="en-US" sz="1400" dirty="0"/>
           </a:p>

</xml_diff>